<commit_message>
Table dollars in $K/$M on 0.1 hr per RO, Warranty Rate Increases, 5% per Employee; Title Case names on the Most Improved grids
Co-Authored-By: Claude Opus 5.5 <noreply@anthropic.com>
Claude-Session: https://claude.ai/code/session_01Xa4nFVxuQGXmHARGph9WhS
</commit_message>
<xml_diff>
--- a/day2-deck/decks/Fixed Gross per Employee 5 Pct - Review.pptx
+++ b/day2-deck/decks/Fixed Gross per Employee 5 Pct - Review.pptx
@@ -1034,8 +1034,8 @@
         </p:nvSpPr>
         <p:spPr>
           <a:xfrm>
-            <a:off x="3419856" y="1316736"/>
-            <a:ext cx="950976" cy="329184"/>
+            <a:off x="3456432" y="1316736"/>
+            <a:ext cx="914400" cy="329184"/>
           </a:xfrm>
           <a:prstGeom prst="rect">
             <a:avLst/>
@@ -1151,8 +1151,8 @@
         </p:nvSpPr>
         <p:spPr>
           <a:xfrm>
-            <a:off x="8970264" y="1316736"/>
-            <a:ext cx="950976" cy="329184"/>
+            <a:off x="9006840" y="1316736"/>
+            <a:ext cx="914400" cy="329184"/>
           </a:xfrm>
           <a:prstGeom prst="rect">
             <a:avLst/>
@@ -1308,7 +1308,7 @@
         <p:spPr>
           <a:xfrm>
             <a:off x="2670048" y="1756697"/>
-            <a:ext cx="694944" cy="136676"/>
+            <a:ext cx="731520" cy="136676"/>
           </a:xfrm>
           <a:prstGeom prst="rect">
             <a:avLst/>
@@ -1327,8 +1327,8 @@
         </p:nvSpPr>
         <p:spPr>
           <a:xfrm>
-            <a:off x="3419856" y="1700784"/>
-            <a:ext cx="950976" cy="248502"/>
+            <a:off x="3456432" y="1700784"/>
+            <a:ext cx="914400" cy="248502"/>
           </a:xfrm>
           <a:prstGeom prst="rect">
             <a:avLst/>
@@ -1352,7 +1352,7 @@
                 <a:ea typeface="Inter" pitchFamily="34" charset="-122"/>
                 <a:cs typeface="Inter" pitchFamily="34" charset="-120"/>
               </a:rPr>
-              <a:t>$1,506,225</a:t>
+              <a:t>$1.51M</a:t>
             </a:r>
             <a:endParaRPr lang="en-US" sz="1300" dirty="0"/>
           </a:p>
@@ -1391,7 +1391,7 @@
                 <a:ea typeface="Inter" pitchFamily="34" charset="-122"/>
                 <a:cs typeface="Inter" pitchFamily="34" charset="-120"/>
               </a:rPr>
-              <a:t>$14,174</a:t>
+              <a:t>$14.2K</a:t>
             </a:r>
             <a:endParaRPr lang="en-US" sz="1300" dirty="0"/>
           </a:p>
@@ -1430,7 +1430,7 @@
                 <a:ea typeface="Inter" pitchFamily="34" charset="-122"/>
                 <a:cs typeface="Inter" pitchFamily="34" charset="-120"/>
               </a:rPr>
-              <a:t>$14,883</a:t>
+              <a:t>$14.9K</a:t>
             </a:r>
             <a:endParaRPr lang="en-US" sz="1300" dirty="0"/>
           </a:p>
@@ -1484,7 +1484,7 @@
         <p:spPr>
           <a:xfrm>
             <a:off x="2670048" y="2005199"/>
-            <a:ext cx="508906" cy="136676"/>
+            <a:ext cx="535690" cy="136676"/>
           </a:xfrm>
           <a:prstGeom prst="rect">
             <a:avLst/>
@@ -1503,8 +1503,8 @@
         </p:nvSpPr>
         <p:spPr>
           <a:xfrm>
-            <a:off x="3419856" y="1949286"/>
-            <a:ext cx="950976" cy="248502"/>
+            <a:off x="3456432" y="1949286"/>
+            <a:ext cx="914400" cy="248502"/>
           </a:xfrm>
           <a:prstGeom prst="rect">
             <a:avLst/>
@@ -1528,7 +1528,7 @@
                 <a:ea typeface="Inter" pitchFamily="34" charset="-122"/>
                 <a:cs typeface="Inter" pitchFamily="34" charset="-120"/>
               </a:rPr>
-              <a:t>$1,103,005</a:t>
+              <a:t>$1.10M</a:t>
             </a:r>
             <a:endParaRPr lang="en-US" sz="1300" dirty="0"/>
           </a:p>
@@ -1567,7 +1567,7 @@
                 <a:ea typeface="Inter" pitchFamily="34" charset="-122"/>
                 <a:cs typeface="Inter" pitchFamily="34" charset="-120"/>
               </a:rPr>
-              <a:t>$12,042</a:t>
+              <a:t>$12.0K</a:t>
             </a:r>
             <a:endParaRPr lang="en-US" sz="1300" dirty="0"/>
           </a:p>
@@ -1606,7 +1606,7 @@
                 <a:ea typeface="Inter" pitchFamily="34" charset="-122"/>
                 <a:cs typeface="Inter" pitchFamily="34" charset="-120"/>
               </a:rPr>
-              <a:t>$12,644</a:t>
+              <a:t>$12.6K</a:t>
             </a:r>
             <a:endParaRPr lang="en-US" sz="1300" dirty="0"/>
           </a:p>
@@ -1660,7 +1660,7 @@
         <p:spPr>
           <a:xfrm>
             <a:off x="2670048" y="2253700"/>
-            <a:ext cx="443634" cy="136676"/>
+            <a:ext cx="466983" cy="136676"/>
           </a:xfrm>
           <a:prstGeom prst="rect">
             <a:avLst/>
@@ -1679,8 +1679,8 @@
         </p:nvSpPr>
         <p:spPr>
           <a:xfrm>
-            <a:off x="3419856" y="2197787"/>
-            <a:ext cx="950976" cy="248502"/>
+            <a:off x="3456432" y="2197787"/>
+            <a:ext cx="914400" cy="248502"/>
           </a:xfrm>
           <a:prstGeom prst="rect">
             <a:avLst/>
@@ -1704,7 +1704,7 @@
                 <a:ea typeface="Inter" pitchFamily="34" charset="-122"/>
                 <a:cs typeface="Inter" pitchFamily="34" charset="-120"/>
               </a:rPr>
-              <a:t>$961,535</a:t>
+              <a:t>$962K</a:t>
             </a:r>
             <a:endParaRPr lang="en-US" sz="1300" dirty="0"/>
           </a:p>
@@ -1743,7 +1743,7 @@
                 <a:ea typeface="Inter" pitchFamily="34" charset="-122"/>
                 <a:cs typeface="Inter" pitchFamily="34" charset="-120"/>
               </a:rPr>
-              <a:t>$16,061</a:t>
+              <a:t>$16.1K</a:t>
             </a:r>
             <a:endParaRPr lang="en-US" sz="1300" dirty="0"/>
           </a:p>
@@ -1782,7 +1782,7 @@
                 <a:ea typeface="Inter" pitchFamily="34" charset="-122"/>
                 <a:cs typeface="Inter" pitchFamily="34" charset="-120"/>
               </a:rPr>
-              <a:t>$16,864</a:t>
+              <a:t>$16.9K</a:t>
             </a:r>
             <a:endParaRPr lang="en-US" sz="1300" dirty="0"/>
           </a:p>
@@ -1836,7 +1836,7 @@
         <p:spPr>
           <a:xfrm>
             <a:off x="2670048" y="2502202"/>
-            <a:ext cx="379571" cy="136676"/>
+            <a:ext cx="399548" cy="136676"/>
           </a:xfrm>
           <a:prstGeom prst="rect">
             <a:avLst/>
@@ -1855,8 +1855,8 @@
         </p:nvSpPr>
         <p:spPr>
           <a:xfrm>
-            <a:off x="3419856" y="2446289"/>
-            <a:ext cx="950976" cy="248502"/>
+            <a:off x="3456432" y="2446289"/>
+            <a:ext cx="914400" cy="248502"/>
           </a:xfrm>
           <a:prstGeom prst="rect">
             <a:avLst/>
@@ -1880,7 +1880,7 @@
                 <a:ea typeface="Inter" pitchFamily="34" charset="-122"/>
                 <a:cs typeface="Inter" pitchFamily="34" charset="-120"/>
               </a:rPr>
-              <a:t>$822,684</a:t>
+              <a:t>$823K</a:t>
             </a:r>
             <a:endParaRPr lang="en-US" sz="1300" dirty="0"/>
           </a:p>
@@ -1919,7 +1919,7 @@
                 <a:ea typeface="Inter" pitchFamily="34" charset="-122"/>
                 <a:cs typeface="Inter" pitchFamily="34" charset="-120"/>
               </a:rPr>
-              <a:t>$23,461</a:t>
+              <a:t>$23.5K</a:t>
             </a:r>
             <a:endParaRPr lang="en-US" sz="1300" dirty="0"/>
           </a:p>
@@ -1958,7 +1958,7 @@
                 <a:ea typeface="Inter" pitchFamily="34" charset="-122"/>
                 <a:cs typeface="Inter" pitchFamily="34" charset="-120"/>
               </a:rPr>
-              <a:t>$24,634</a:t>
+              <a:t>$24.6K</a:t>
             </a:r>
             <a:endParaRPr lang="en-US" sz="1300" dirty="0"/>
           </a:p>
@@ -2012,7 +2012,7 @@
         <p:spPr>
           <a:xfrm>
             <a:off x="2670048" y="2750703"/>
-            <a:ext cx="310060" cy="136676"/>
+            <a:ext cx="326379" cy="136676"/>
           </a:xfrm>
           <a:prstGeom prst="rect">
             <a:avLst/>
@@ -2031,8 +2031,8 @@
         </p:nvSpPr>
         <p:spPr>
           <a:xfrm>
-            <a:off x="3419856" y="2694791"/>
-            <a:ext cx="950976" cy="248502"/>
+            <a:off x="3456432" y="2694791"/>
+            <a:ext cx="914400" cy="248502"/>
           </a:xfrm>
           <a:prstGeom prst="rect">
             <a:avLst/>
@@ -2056,7 +2056,7 @@
                 <a:ea typeface="Inter" pitchFamily="34" charset="-122"/>
                 <a:cs typeface="Inter" pitchFamily="34" charset="-120"/>
               </a:rPr>
-              <a:t>$672,026</a:t>
+              <a:t>$672K</a:t>
             </a:r>
             <a:endParaRPr lang="en-US" sz="1300" dirty="0"/>
           </a:p>
@@ -2095,7 +2095,7 @@
                 <a:ea typeface="Inter" pitchFamily="34" charset="-122"/>
                 <a:cs typeface="Inter" pitchFamily="34" charset="-120"/>
               </a:rPr>
-              <a:t>$12,874</a:t>
+              <a:t>$12.9K</a:t>
             </a:r>
             <a:endParaRPr lang="en-US" sz="1300" dirty="0"/>
           </a:p>
@@ -2134,7 +2134,7 @@
                 <a:ea typeface="Inter" pitchFamily="34" charset="-122"/>
                 <a:cs typeface="Inter" pitchFamily="34" charset="-120"/>
               </a:rPr>
-              <a:t>$13,518</a:t>
+              <a:t>$13.5K</a:t>
             </a:r>
             <a:endParaRPr lang="en-US" sz="1300" dirty="0"/>
           </a:p>
@@ -2188,7 +2188,7 @@
         <p:spPr>
           <a:xfrm>
             <a:off x="2670048" y="2999205"/>
-            <a:ext cx="295191" cy="136676"/>
+            <a:ext cx="310728" cy="136676"/>
           </a:xfrm>
           <a:prstGeom prst="rect">
             <a:avLst/>
@@ -2207,8 +2207,8 @@
         </p:nvSpPr>
         <p:spPr>
           <a:xfrm>
-            <a:off x="3419856" y="2943292"/>
-            <a:ext cx="950976" cy="248502"/>
+            <a:off x="3456432" y="2943292"/>
+            <a:ext cx="914400" cy="248502"/>
           </a:xfrm>
           <a:prstGeom prst="rect">
             <a:avLst/>
@@ -2232,7 +2232,7 @@
                 <a:ea typeface="Inter" pitchFamily="34" charset="-122"/>
                 <a:cs typeface="Inter" pitchFamily="34" charset="-120"/>
               </a:rPr>
-              <a:t>$639,799</a:t>
+              <a:t>$640K</a:t>
             </a:r>
             <a:endParaRPr lang="en-US" sz="1300" dirty="0"/>
           </a:p>
@@ -2271,7 +2271,7 @@
                 <a:ea typeface="Inter" pitchFamily="34" charset="-122"/>
                 <a:cs typeface="Inter" pitchFamily="34" charset="-120"/>
               </a:rPr>
-              <a:t>$14,260</a:t>
+              <a:t>$14.3K</a:t>
             </a:r>
             <a:endParaRPr lang="en-US" sz="1300" dirty="0"/>
           </a:p>
@@ -2310,7 +2310,7 @@
                 <a:ea typeface="Inter" pitchFamily="34" charset="-122"/>
                 <a:cs typeface="Inter" pitchFamily="34" charset="-120"/>
               </a:rPr>
-              <a:t>$14,973</a:t>
+              <a:t>$15.0K</a:t>
             </a:r>
             <a:endParaRPr lang="en-US" sz="1300" dirty="0"/>
           </a:p>
@@ -2364,7 +2364,7 @@
         <p:spPr>
           <a:xfrm>
             <a:off x="2670048" y="3247707"/>
-            <a:ext cx="265029" cy="136676"/>
+            <a:ext cx="278978" cy="136676"/>
           </a:xfrm>
           <a:prstGeom prst="rect">
             <a:avLst/>
@@ -2383,8 +2383,8 @@
         </p:nvSpPr>
         <p:spPr>
           <a:xfrm>
-            <a:off x="3419856" y="3191794"/>
-            <a:ext cx="950976" cy="248502"/>
+            <a:off x="3456432" y="3191794"/>
+            <a:ext cx="914400" cy="248502"/>
           </a:xfrm>
           <a:prstGeom prst="rect">
             <a:avLst/>
@@ -2408,7 +2408,7 @@
                 <a:ea typeface="Inter" pitchFamily="34" charset="-122"/>
                 <a:cs typeface="Inter" pitchFamily="34" charset="-120"/>
               </a:rPr>
-              <a:t>$574,425</a:t>
+              <a:t>$574K</a:t>
             </a:r>
             <a:endParaRPr lang="en-US" sz="1300" dirty="0"/>
           </a:p>
@@ -2447,7 +2447,7 @@
                 <a:ea typeface="Inter" pitchFamily="34" charset="-122"/>
                 <a:cs typeface="Inter" pitchFamily="34" charset="-120"/>
               </a:rPr>
-              <a:t>$14,604</a:t>
+              <a:t>$14.6K</a:t>
             </a:r>
             <a:endParaRPr lang="en-US" sz="1300" dirty="0"/>
           </a:p>
@@ -2486,7 +2486,7 @@
                 <a:ea typeface="Inter" pitchFamily="34" charset="-122"/>
                 <a:cs typeface="Inter" pitchFamily="34" charset="-120"/>
               </a:rPr>
-              <a:t>$15,334</a:t>
+              <a:t>$15.3K</a:t>
             </a:r>
             <a:endParaRPr lang="en-US" sz="1300" dirty="0"/>
           </a:p>
@@ -2540,7 +2540,7 @@
         <p:spPr>
           <a:xfrm>
             <a:off x="2670048" y="3496208"/>
-            <a:ext cx="203194" cy="136676"/>
+            <a:ext cx="213888" cy="136676"/>
           </a:xfrm>
           <a:prstGeom prst="rect">
             <a:avLst/>
@@ -2559,8 +2559,8 @@
         </p:nvSpPr>
         <p:spPr>
           <a:xfrm>
-            <a:off x="3419856" y="3440296"/>
-            <a:ext cx="950976" cy="248502"/>
+            <a:off x="3456432" y="3440296"/>
+            <a:ext cx="914400" cy="248502"/>
           </a:xfrm>
           <a:prstGeom prst="rect">
             <a:avLst/>
@@ -2584,7 +2584,7 @@
                 <a:ea typeface="Inter" pitchFamily="34" charset="-122"/>
                 <a:cs typeface="Inter" pitchFamily="34" charset="-120"/>
               </a:rPr>
-              <a:t>$440,403</a:t>
+              <a:t>$440K</a:t>
             </a:r>
             <a:endParaRPr lang="en-US" sz="1300" dirty="0"/>
           </a:p>
@@ -2623,7 +2623,7 @@
                 <a:ea typeface="Inter" pitchFamily="34" charset="-122"/>
                 <a:cs typeface="Inter" pitchFamily="34" charset="-120"/>
               </a:rPr>
-              <a:t>$18,148</a:t>
+              <a:t>$18.1K</a:t>
             </a:r>
             <a:endParaRPr lang="en-US" sz="1300" dirty="0"/>
           </a:p>
@@ -2662,7 +2662,7 @@
                 <a:ea typeface="Inter" pitchFamily="34" charset="-122"/>
                 <a:cs typeface="Inter" pitchFamily="34" charset="-120"/>
               </a:rPr>
-              <a:t>$19,056</a:t>
+              <a:t>$19.1K</a:t>
             </a:r>
             <a:endParaRPr lang="en-US" sz="1300" dirty="0"/>
           </a:p>
@@ -2716,7 +2716,7 @@
         <p:spPr>
           <a:xfrm>
             <a:off x="2670048" y="3744710"/>
-            <a:ext cx="189258" cy="136676"/>
+            <a:ext cx="199219" cy="136676"/>
           </a:xfrm>
           <a:prstGeom prst="rect">
             <a:avLst/>
@@ -2735,8 +2735,8 @@
         </p:nvSpPr>
         <p:spPr>
           <a:xfrm>
-            <a:off x="3419856" y="3688797"/>
-            <a:ext cx="950976" cy="248502"/>
+            <a:off x="3456432" y="3688797"/>
+            <a:ext cx="914400" cy="248502"/>
           </a:xfrm>
           <a:prstGeom prst="rect">
             <a:avLst/>
@@ -2760,7 +2760,7 @@
                 <a:ea typeface="Inter" pitchFamily="34" charset="-122"/>
                 <a:cs typeface="Inter" pitchFamily="34" charset="-120"/>
               </a:rPr>
-              <a:t>$410,199</a:t>
+              <a:t>$410K</a:t>
             </a:r>
             <a:endParaRPr lang="en-US" sz="1300" dirty="0"/>
           </a:p>
@@ -2799,7 +2799,7 @@
                 <a:ea typeface="Inter" pitchFamily="34" charset="-122"/>
                 <a:cs typeface="Inter" pitchFamily="34" charset="-120"/>
               </a:rPr>
-              <a:t>$13,289</a:t>
+              <a:t>$13.3K</a:t>
             </a:r>
             <a:endParaRPr lang="en-US" sz="1300" dirty="0"/>
           </a:p>
@@ -2838,7 +2838,7 @@
                 <a:ea typeface="Inter" pitchFamily="34" charset="-122"/>
                 <a:cs typeface="Inter" pitchFamily="34" charset="-120"/>
               </a:rPr>
-              <a:t>$13,954</a:t>
+              <a:t>$14.0K</a:t>
             </a:r>
             <a:endParaRPr lang="en-US" sz="1300" dirty="0"/>
           </a:p>
@@ -2892,7 +2892,7 @@
         <p:spPr>
           <a:xfrm>
             <a:off x="2670048" y="3993212"/>
-            <a:ext cx="182441" cy="136676"/>
+            <a:ext cx="192043" cy="136676"/>
           </a:xfrm>
           <a:prstGeom prst="rect">
             <a:avLst/>
@@ -2911,8 +2911,8 @@
         </p:nvSpPr>
         <p:spPr>
           <a:xfrm>
-            <a:off x="3419856" y="3937299"/>
-            <a:ext cx="950976" cy="248502"/>
+            <a:off x="3456432" y="3937299"/>
+            <a:ext cx="914400" cy="248502"/>
           </a:xfrm>
           <a:prstGeom prst="rect">
             <a:avLst/>
@@ -2936,7 +2936,7 @@
                 <a:ea typeface="Inter" pitchFamily="34" charset="-122"/>
                 <a:cs typeface="Inter" pitchFamily="34" charset="-120"/>
               </a:rPr>
-              <a:t>$395,423</a:t>
+              <a:t>$395K</a:t>
             </a:r>
             <a:endParaRPr lang="en-US" sz="1300" dirty="0"/>
           </a:p>
@@ -2975,7 +2975,7 @@
                 <a:ea typeface="Inter" pitchFamily="34" charset="-122"/>
                 <a:cs typeface="Inter" pitchFamily="34" charset="-120"/>
               </a:rPr>
-              <a:t>$11,128</a:t>
+              <a:t>$11.1K</a:t>
             </a:r>
             <a:endParaRPr lang="en-US" sz="1300" dirty="0"/>
           </a:p>
@@ -3014,7 +3014,7 @@
                 <a:ea typeface="Inter" pitchFamily="34" charset="-122"/>
                 <a:cs typeface="Inter" pitchFamily="34" charset="-120"/>
               </a:rPr>
-              <a:t>$11,685</a:t>
+              <a:t>$11.7K</a:t>
             </a:r>
             <a:endParaRPr lang="en-US" sz="1300" dirty="0"/>
           </a:p>
@@ -3068,7 +3068,7 @@
         <p:spPr>
           <a:xfrm>
             <a:off x="2670048" y="4241713"/>
-            <a:ext cx="156263" cy="136676"/>
+            <a:ext cx="164487" cy="136676"/>
           </a:xfrm>
           <a:prstGeom prst="rect">
             <a:avLst/>
@@ -3087,8 +3087,8 @@
         </p:nvSpPr>
         <p:spPr>
           <a:xfrm>
-            <a:off x="3419856" y="4185800"/>
-            <a:ext cx="950976" cy="248502"/>
+            <a:off x="3456432" y="4185800"/>
+            <a:ext cx="914400" cy="248502"/>
           </a:xfrm>
           <a:prstGeom prst="rect">
             <a:avLst/>
@@ -3112,7 +3112,7 @@
                 <a:ea typeface="Inter" pitchFamily="34" charset="-122"/>
                 <a:cs typeface="Inter" pitchFamily="34" charset="-120"/>
               </a:rPr>
-              <a:t>$338,685</a:t>
+              <a:t>$339K</a:t>
             </a:r>
             <a:endParaRPr lang="en-US" sz="1300" dirty="0"/>
           </a:p>
@@ -3151,7 +3151,7 @@
                 <a:ea typeface="Inter" pitchFamily="34" charset="-122"/>
                 <a:cs typeface="Inter" pitchFamily="34" charset="-120"/>
               </a:rPr>
-              <a:t>$11,044</a:t>
+              <a:t>$11.0K</a:t>
             </a:r>
             <a:endParaRPr lang="en-US" sz="1300" dirty="0"/>
           </a:p>
@@ -3190,7 +3190,7 @@
                 <a:ea typeface="Inter" pitchFamily="34" charset="-122"/>
                 <a:cs typeface="Inter" pitchFamily="34" charset="-120"/>
               </a:rPr>
-              <a:t>$11,596</a:t>
+              <a:t>$11.6K</a:t>
             </a:r>
             <a:endParaRPr lang="en-US" sz="1300" dirty="0"/>
           </a:p>
@@ -3244,7 +3244,7 @@
         <p:spPr>
           <a:xfrm>
             <a:off x="2670048" y="4490215"/>
-            <a:ext cx="147344" cy="136676"/>
+            <a:ext cx="155099" cy="136676"/>
           </a:xfrm>
           <a:prstGeom prst="rect">
             <a:avLst/>
@@ -3263,8 +3263,8 @@
         </p:nvSpPr>
         <p:spPr>
           <a:xfrm>
-            <a:off x="3419856" y="4434302"/>
-            <a:ext cx="950976" cy="248502"/>
+            <a:off x="3456432" y="4434302"/>
+            <a:ext cx="914400" cy="248502"/>
           </a:xfrm>
           <a:prstGeom prst="rect">
             <a:avLst/>
@@ -3288,7 +3288,7 @@
                 <a:ea typeface="Inter" pitchFamily="34" charset="-122"/>
                 <a:cs typeface="Inter" pitchFamily="34" charset="-120"/>
               </a:rPr>
-              <a:t>$319,353</a:t>
+              <a:t>$319K</a:t>
             </a:r>
             <a:endParaRPr lang="en-US" sz="1300" dirty="0"/>
           </a:p>
@@ -3327,7 +3327,7 @@
                 <a:ea typeface="Inter" pitchFamily="34" charset="-122"/>
                 <a:cs typeface="Inter" pitchFamily="34" charset="-120"/>
               </a:rPr>
-              <a:t>$12,006</a:t>
+              <a:t>$12.0K</a:t>
             </a:r>
             <a:endParaRPr lang="en-US" sz="1300" dirty="0"/>
           </a:p>
@@ -3366,7 +3366,7 @@
                 <a:ea typeface="Inter" pitchFamily="34" charset="-122"/>
                 <a:cs typeface="Inter" pitchFamily="34" charset="-120"/>
               </a:rPr>
-              <a:t>$12,606</a:t>
+              <a:t>$12.6K</a:t>
             </a:r>
             <a:endParaRPr lang="en-US" sz="1300" dirty="0"/>
           </a:p>
@@ -3420,7 +3420,7 @@
         <p:spPr>
           <a:xfrm>
             <a:off x="2670048" y="4738717"/>
-            <a:ext cx="147118" cy="136676"/>
+            <a:ext cx="154861" cy="136676"/>
           </a:xfrm>
           <a:prstGeom prst="rect">
             <a:avLst/>
@@ -3439,8 +3439,8 @@
         </p:nvSpPr>
         <p:spPr>
           <a:xfrm>
-            <a:off x="3419856" y="4682804"/>
-            <a:ext cx="950976" cy="248502"/>
+            <a:off x="3456432" y="4682804"/>
+            <a:ext cx="914400" cy="248502"/>
           </a:xfrm>
           <a:prstGeom prst="rect">
             <a:avLst/>
@@ -3464,7 +3464,7 @@
                 <a:ea typeface="Inter" pitchFamily="34" charset="-122"/>
                 <a:cs typeface="Inter" pitchFamily="34" charset="-120"/>
               </a:rPr>
-              <a:t>$318,864</a:t>
+              <a:t>$319K</a:t>
             </a:r>
             <a:endParaRPr lang="en-US" sz="1300" dirty="0"/>
           </a:p>
@@ -3503,7 +3503,7 @@
                 <a:ea typeface="Inter" pitchFamily="34" charset="-122"/>
                 <a:cs typeface="Inter" pitchFamily="34" charset="-120"/>
               </a:rPr>
-              <a:t>$11,957</a:t>
+              <a:t>$12.0K</a:t>
             </a:r>
             <a:endParaRPr lang="en-US" sz="1300" dirty="0"/>
           </a:p>
@@ -3542,7 +3542,7 @@
                 <a:ea typeface="Inter" pitchFamily="34" charset="-122"/>
                 <a:cs typeface="Inter" pitchFamily="34" charset="-120"/>
               </a:rPr>
-              <a:t>$12,555</a:t>
+              <a:t>$12.6K</a:t>
             </a:r>
             <a:endParaRPr lang="en-US" sz="1300" dirty="0"/>
           </a:p>
@@ -3596,7 +3596,7 @@
         <p:spPr>
           <a:xfrm>
             <a:off x="2670048" y="4987218"/>
-            <a:ext cx="139353" cy="136676"/>
+            <a:ext cx="146688" cy="136676"/>
           </a:xfrm>
           <a:prstGeom prst="rect">
             <a:avLst/>
@@ -3615,8 +3615,8 @@
         </p:nvSpPr>
         <p:spPr>
           <a:xfrm>
-            <a:off x="3419856" y="4931305"/>
-            <a:ext cx="950976" cy="248502"/>
+            <a:off x="3456432" y="4931305"/>
+            <a:ext cx="914400" cy="248502"/>
           </a:xfrm>
           <a:prstGeom prst="rect">
             <a:avLst/>
@@ -3640,7 +3640,7 @@
                 <a:ea typeface="Inter" pitchFamily="34" charset="-122"/>
                 <a:cs typeface="Inter" pitchFamily="34" charset="-120"/>
               </a:rPr>
-              <a:t>$302,035</a:t>
+              <a:t>$302K</a:t>
             </a:r>
             <a:endParaRPr lang="en-US" sz="1300" dirty="0"/>
           </a:p>
@@ -3679,7 +3679,7 @@
                 <a:ea typeface="Inter" pitchFamily="34" charset="-122"/>
                 <a:cs typeface="Inter" pitchFamily="34" charset="-120"/>
               </a:rPr>
-              <a:t>$10,391</a:t>
+              <a:t>$10.4K</a:t>
             </a:r>
             <a:endParaRPr lang="en-US" sz="1300" dirty="0"/>
           </a:p>
@@ -3718,7 +3718,7 @@
                 <a:ea typeface="Inter" pitchFamily="34" charset="-122"/>
                 <a:cs typeface="Inter" pitchFamily="34" charset="-120"/>
               </a:rPr>
-              <a:t>$10,911</a:t>
+              <a:t>$10.9K</a:t>
             </a:r>
             <a:endParaRPr lang="en-US" sz="1300" dirty="0"/>
           </a:p>
@@ -3772,7 +3772,7 @@
         <p:spPr>
           <a:xfrm>
             <a:off x="2670048" y="5235720"/>
-            <a:ext cx="137448" cy="136676"/>
+            <a:ext cx="144683" cy="136676"/>
           </a:xfrm>
           <a:prstGeom prst="rect">
             <a:avLst/>
@@ -3791,8 +3791,8 @@
         </p:nvSpPr>
         <p:spPr>
           <a:xfrm>
-            <a:off x="3419856" y="5179807"/>
-            <a:ext cx="950976" cy="248502"/>
+            <a:off x="3456432" y="5179807"/>
+            <a:ext cx="914400" cy="248502"/>
           </a:xfrm>
           <a:prstGeom prst="rect">
             <a:avLst/>
@@ -3816,7 +3816,7 @@
                 <a:ea typeface="Inter" pitchFamily="34" charset="-122"/>
                 <a:cs typeface="Inter" pitchFamily="34" charset="-120"/>
               </a:rPr>
-              <a:t>$297,906</a:t>
+              <a:t>$298K</a:t>
             </a:r>
             <a:endParaRPr lang="en-US" sz="1300" dirty="0"/>
           </a:p>
@@ -3855,7 +3855,7 @@
                 <a:ea typeface="Inter" pitchFamily="34" charset="-122"/>
                 <a:cs typeface="Inter" pitchFamily="34" charset="-120"/>
               </a:rPr>
-              <a:t>$10,794</a:t>
+              <a:t>$10.8K</a:t>
             </a:r>
             <a:endParaRPr lang="en-US" sz="1300" dirty="0"/>
           </a:p>
@@ -3894,7 +3894,7 @@
                 <a:ea typeface="Inter" pitchFamily="34" charset="-122"/>
                 <a:cs typeface="Inter" pitchFamily="34" charset="-120"/>
               </a:rPr>
-              <a:t>$11,333</a:t>
+              <a:t>$11.3K</a:t>
             </a:r>
             <a:endParaRPr lang="en-US" sz="1300" dirty="0"/>
           </a:p>
@@ -3948,7 +3948,7 @@
         <p:spPr>
           <a:xfrm>
             <a:off x="2670048" y="5484222"/>
-            <a:ext cx="137179" cy="136676"/>
+            <a:ext cx="144399" cy="136676"/>
           </a:xfrm>
           <a:prstGeom prst="rect">
             <a:avLst/>
@@ -3967,8 +3967,8 @@
         </p:nvSpPr>
         <p:spPr>
           <a:xfrm>
-            <a:off x="3419856" y="5428309"/>
-            <a:ext cx="950976" cy="248502"/>
+            <a:off x="3456432" y="5428309"/>
+            <a:ext cx="914400" cy="248502"/>
           </a:xfrm>
           <a:prstGeom prst="rect">
             <a:avLst/>
@@ -3992,7 +3992,7 @@
                 <a:ea typeface="Inter" pitchFamily="34" charset="-122"/>
                 <a:cs typeface="Inter" pitchFamily="34" charset="-120"/>
               </a:rPr>
-              <a:t>$297,322</a:t>
+              <a:t>$297K</a:t>
             </a:r>
             <a:endParaRPr lang="en-US" sz="1300" dirty="0"/>
           </a:p>
@@ -4031,7 +4031,7 @@
                 <a:ea typeface="Inter" pitchFamily="34" charset="-122"/>
                 <a:cs typeface="Inter" pitchFamily="34" charset="-120"/>
               </a:rPr>
-              <a:t>$14,916</a:t>
+              <a:t>$14.9K</a:t>
             </a:r>
             <a:endParaRPr lang="en-US" sz="1300" dirty="0"/>
           </a:p>
@@ -4070,7 +4070,7 @@
                 <a:ea typeface="Inter" pitchFamily="34" charset="-122"/>
                 <a:cs typeface="Inter" pitchFamily="34" charset="-120"/>
               </a:rPr>
-              <a:t>$15,662</a:t>
+              <a:t>$15.7K</a:t>
             </a:r>
             <a:endParaRPr lang="en-US" sz="1300" dirty="0"/>
           </a:p>
@@ -4124,7 +4124,7 @@
         <p:spPr>
           <a:xfrm>
             <a:off x="2670048" y="5732723"/>
-            <a:ext cx="128662" cy="136676"/>
+            <a:ext cx="135434" cy="136676"/>
           </a:xfrm>
           <a:prstGeom prst="rect">
             <a:avLst/>
@@ -4143,8 +4143,8 @@
         </p:nvSpPr>
         <p:spPr>
           <a:xfrm>
-            <a:off x="3419856" y="5676810"/>
-            <a:ext cx="950976" cy="248502"/>
+            <a:off x="3456432" y="5676810"/>
+            <a:ext cx="914400" cy="248502"/>
           </a:xfrm>
           <a:prstGeom prst="rect">
             <a:avLst/>
@@ -4168,7 +4168,7 @@
                 <a:ea typeface="Inter" pitchFamily="34" charset="-122"/>
                 <a:cs typeface="Inter" pitchFamily="34" charset="-120"/>
               </a:rPr>
-              <a:t>$278,863</a:t>
+              <a:t>$279K</a:t>
             </a:r>
             <a:endParaRPr lang="en-US" sz="1300" dirty="0"/>
           </a:p>
@@ -4207,7 +4207,7 @@
                 <a:ea typeface="Inter" pitchFamily="34" charset="-122"/>
                 <a:cs typeface="Inter" pitchFamily="34" charset="-120"/>
               </a:rPr>
-              <a:t>$12,871</a:t>
+              <a:t>$12.9K</a:t>
             </a:r>
             <a:endParaRPr lang="en-US" sz="1300" dirty="0"/>
           </a:p>
@@ -4246,7 +4246,7 @@
                 <a:ea typeface="Inter" pitchFamily="34" charset="-122"/>
                 <a:cs typeface="Inter" pitchFamily="34" charset="-120"/>
               </a:rPr>
-              <a:t>$13,514</a:t>
+              <a:t>$13.5K</a:t>
             </a:r>
             <a:endParaRPr lang="en-US" sz="1300" dirty="0"/>
           </a:p>
@@ -4300,7 +4300,7 @@
         <p:spPr>
           <a:xfrm>
             <a:off x="8220456" y="1756697"/>
-            <a:ext cx="127501" cy="136676"/>
+            <a:ext cx="134212" cy="136676"/>
           </a:xfrm>
           <a:prstGeom prst="rect">
             <a:avLst/>
@@ -4319,8 +4319,8 @@
         </p:nvSpPr>
         <p:spPr>
           <a:xfrm>
-            <a:off x="8970264" y="1700784"/>
-            <a:ext cx="950976" cy="248502"/>
+            <a:off x="9006840" y="1700784"/>
+            <a:ext cx="914400" cy="248502"/>
           </a:xfrm>
           <a:prstGeom prst="rect">
             <a:avLst/>
@@ -4344,7 +4344,7 @@
                 <a:ea typeface="Inter" pitchFamily="34" charset="-122"/>
                 <a:cs typeface="Inter" pitchFamily="34" charset="-120"/>
               </a:rPr>
-              <a:t>$276,346</a:t>
+              <a:t>$276K</a:t>
             </a:r>
             <a:endParaRPr lang="en-US" sz="1300" dirty="0"/>
           </a:p>
@@ -4383,7 +4383,7 @@
                 <a:ea typeface="Inter" pitchFamily="34" charset="-122"/>
                 <a:cs typeface="Inter" pitchFamily="34" charset="-120"/>
               </a:rPr>
-              <a:t>$16,919</a:t>
+              <a:t>$16.9K</a:t>
             </a:r>
             <a:endParaRPr lang="en-US" sz="1300" dirty="0"/>
           </a:p>
@@ -4422,7 +4422,7 @@
                 <a:ea typeface="Inter" pitchFamily="34" charset="-122"/>
                 <a:cs typeface="Inter" pitchFamily="34" charset="-120"/>
               </a:rPr>
-              <a:t>$17,765</a:t>
+              <a:t>$17.8K</a:t>
             </a:r>
             <a:endParaRPr lang="en-US" sz="1300" dirty="0"/>
           </a:p>
@@ -4476,7 +4476,7 @@
         <p:spPr>
           <a:xfrm>
             <a:off x="8220456" y="2005199"/>
-            <a:ext cx="120382" cy="136676"/>
+            <a:ext cx="126718" cy="136676"/>
           </a:xfrm>
           <a:prstGeom prst="rect">
             <a:avLst/>
@@ -4495,8 +4495,8 @@
         </p:nvSpPr>
         <p:spPr>
           <a:xfrm>
-            <a:off x="8970264" y="1949286"/>
-            <a:ext cx="950976" cy="248502"/>
+            <a:off x="9006840" y="1949286"/>
+            <a:ext cx="914400" cy="248502"/>
           </a:xfrm>
           <a:prstGeom prst="rect">
             <a:avLst/>
@@ -4520,7 +4520,7 @@
                 <a:ea typeface="Inter" pitchFamily="34" charset="-122"/>
                 <a:cs typeface="Inter" pitchFamily="34" charset="-120"/>
               </a:rPr>
-              <a:t>$260,917</a:t>
+              <a:t>$261K</a:t>
             </a:r>
             <a:endParaRPr lang="en-US" sz="1300" dirty="0"/>
           </a:p>
@@ -4559,7 +4559,7 @@
                 <a:ea typeface="Inter" pitchFamily="34" charset="-122"/>
                 <a:cs typeface="Inter" pitchFamily="34" charset="-120"/>
               </a:rPr>
-              <a:t>$18,549</a:t>
+              <a:t>$18.5K</a:t>
             </a:r>
             <a:endParaRPr lang="en-US" sz="1300" dirty="0"/>
           </a:p>
@@ -4598,7 +4598,7 @@
                 <a:ea typeface="Inter" pitchFamily="34" charset="-122"/>
                 <a:cs typeface="Inter" pitchFamily="34" charset="-120"/>
               </a:rPr>
-              <a:t>$19,476</a:t>
+              <a:t>$19.5K</a:t>
             </a:r>
             <a:endParaRPr lang="en-US" sz="1300" dirty="0"/>
           </a:p>
@@ -4652,7 +4652,7 @@
         <p:spPr>
           <a:xfrm>
             <a:off x="8220456" y="2253700"/>
-            <a:ext cx="109290" cy="136676"/>
+            <a:ext cx="115043" cy="136676"/>
           </a:xfrm>
           <a:prstGeom prst="rect">
             <a:avLst/>
@@ -4671,8 +4671,8 @@
         </p:nvSpPr>
         <p:spPr>
           <a:xfrm>
-            <a:off x="8970264" y="2197787"/>
-            <a:ext cx="950976" cy="248502"/>
+            <a:off x="9006840" y="2197787"/>
+            <a:ext cx="914400" cy="248502"/>
           </a:xfrm>
           <a:prstGeom prst="rect">
             <a:avLst/>
@@ -4696,7 +4696,7 @@
                 <a:ea typeface="Inter" pitchFamily="34" charset="-122"/>
                 <a:cs typeface="Inter" pitchFamily="34" charset="-120"/>
               </a:rPr>
-              <a:t>$236,877</a:t>
+              <a:t>$237K</a:t>
             </a:r>
             <a:endParaRPr lang="en-US" sz="1300" dirty="0"/>
           </a:p>
@@ -4735,7 +4735,7 @@
                 <a:ea typeface="Inter" pitchFamily="34" charset="-122"/>
                 <a:cs typeface="Inter" pitchFamily="34" charset="-120"/>
               </a:rPr>
-              <a:t>$9,953</a:t>
+              <a:t>$10.0K</a:t>
             </a:r>
             <a:endParaRPr lang="en-US" sz="1300" dirty="0"/>
           </a:p>
@@ -4774,7 +4774,7 @@
                 <a:ea typeface="Inter" pitchFamily="34" charset="-122"/>
                 <a:cs typeface="Inter" pitchFamily="34" charset="-120"/>
               </a:rPr>
-              <a:t>$10,450</a:t>
+              <a:t>$10.5K</a:t>
             </a:r>
             <a:endParaRPr lang="en-US" sz="1300" dirty="0"/>
           </a:p>
@@ -4828,7 +4828,7 @@
         <p:spPr>
           <a:xfrm>
             <a:off x="8220456" y="2502202"/>
-            <a:ext cx="108135" cy="136676"/>
+            <a:ext cx="113826" cy="136676"/>
           </a:xfrm>
           <a:prstGeom prst="rect">
             <a:avLst/>
@@ -4847,8 +4847,8 @@
         </p:nvSpPr>
         <p:spPr>
           <a:xfrm>
-            <a:off x="8970264" y="2446289"/>
-            <a:ext cx="950976" cy="248502"/>
+            <a:off x="9006840" y="2446289"/>
+            <a:ext cx="914400" cy="248502"/>
           </a:xfrm>
           <a:prstGeom prst="rect">
             <a:avLst/>
@@ -4872,7 +4872,7 @@
                 <a:ea typeface="Inter" pitchFamily="34" charset="-122"/>
                 <a:cs typeface="Inter" pitchFamily="34" charset="-120"/>
               </a:rPr>
-              <a:t>$234,372</a:t>
+              <a:t>$234K</a:t>
             </a:r>
             <a:endParaRPr lang="en-US" sz="1300" dirty="0"/>
           </a:p>
@@ -4911,7 +4911,7 @@
                 <a:ea typeface="Inter" pitchFamily="34" charset="-122"/>
                 <a:cs typeface="Inter" pitchFamily="34" charset="-120"/>
               </a:rPr>
-              <a:t>$15,556</a:t>
+              <a:t>$15.6K</a:t>
             </a:r>
             <a:endParaRPr lang="en-US" sz="1300" dirty="0"/>
           </a:p>
@@ -4950,7 +4950,7 @@
                 <a:ea typeface="Inter" pitchFamily="34" charset="-122"/>
                 <a:cs typeface="Inter" pitchFamily="34" charset="-120"/>
               </a:rPr>
-              <a:t>$16,333</a:t>
+              <a:t>$16.3K</a:t>
             </a:r>
             <a:endParaRPr lang="en-US" sz="1300" dirty="0"/>
           </a:p>
@@ -5004,7 +5004,7 @@
         <p:spPr>
           <a:xfrm>
             <a:off x="8220456" y="2750703"/>
-            <a:ext cx="105077" cy="136676"/>
+            <a:ext cx="110607" cy="136676"/>
           </a:xfrm>
           <a:prstGeom prst="rect">
             <a:avLst/>
@@ -5023,8 +5023,8 @@
         </p:nvSpPr>
         <p:spPr>
           <a:xfrm>
-            <a:off x="8970264" y="2694791"/>
-            <a:ext cx="950976" cy="248502"/>
+            <a:off x="9006840" y="2694791"/>
+            <a:ext cx="914400" cy="248502"/>
           </a:xfrm>
           <a:prstGeom prst="rect">
             <a:avLst/>
@@ -5048,7 +5048,7 @@
                 <a:ea typeface="Inter" pitchFamily="34" charset="-122"/>
                 <a:cs typeface="Inter" pitchFamily="34" charset="-120"/>
               </a:rPr>
-              <a:t>$227,743</a:t>
+              <a:t>$228K</a:t>
             </a:r>
             <a:endParaRPr lang="en-US" sz="1300" dirty="0"/>
           </a:p>
@@ -5087,7 +5087,7 @@
                 <a:ea typeface="Inter" pitchFamily="34" charset="-122"/>
                 <a:cs typeface="Inter" pitchFamily="34" charset="-120"/>
               </a:rPr>
-              <a:t>$18,268</a:t>
+              <a:t>$18.3K</a:t>
             </a:r>
             <a:endParaRPr lang="en-US" sz="1300" dirty="0"/>
           </a:p>
@@ -5126,7 +5126,7 @@
                 <a:ea typeface="Inter" pitchFamily="34" charset="-122"/>
                 <a:cs typeface="Inter" pitchFamily="34" charset="-120"/>
               </a:rPr>
-              <a:t>$19,182</a:t>
+              <a:t>$19.2K</a:t>
             </a:r>
             <a:endParaRPr lang="en-US" sz="1300" dirty="0"/>
           </a:p>
@@ -5180,7 +5180,7 @@
         <p:spPr>
           <a:xfrm>
             <a:off x="8220456" y="2999205"/>
-            <a:ext cx="101658" cy="136676"/>
+            <a:ext cx="107009" cy="136676"/>
           </a:xfrm>
           <a:prstGeom prst="rect">
             <a:avLst/>
@@ -5199,8 +5199,8 @@
         </p:nvSpPr>
         <p:spPr>
           <a:xfrm>
-            <a:off x="8970264" y="2943292"/>
-            <a:ext cx="950976" cy="248502"/>
+            <a:off x="9006840" y="2943292"/>
+            <a:ext cx="914400" cy="248502"/>
           </a:xfrm>
           <a:prstGeom prst="rect">
             <a:avLst/>
@@ -5224,7 +5224,7 @@
                 <a:ea typeface="Inter" pitchFamily="34" charset="-122"/>
                 <a:cs typeface="Inter" pitchFamily="34" charset="-120"/>
               </a:rPr>
-              <a:t>$220,335</a:t>
+              <a:t>$220K</a:t>
             </a:r>
             <a:endParaRPr lang="en-US" sz="1300" dirty="0"/>
           </a:p>
@@ -5263,7 +5263,7 @@
                 <a:ea typeface="Inter" pitchFamily="34" charset="-122"/>
                 <a:cs typeface="Inter" pitchFamily="34" charset="-120"/>
               </a:rPr>
-              <a:t>$15,966</a:t>
+              <a:t>$16.0K</a:t>
             </a:r>
             <a:endParaRPr lang="en-US" sz="1300" dirty="0"/>
           </a:p>
@@ -5302,7 +5302,7 @@
                 <a:ea typeface="Inter" pitchFamily="34" charset="-122"/>
                 <a:cs typeface="Inter" pitchFamily="34" charset="-120"/>
               </a:rPr>
-              <a:t>$16,765</a:t>
+              <a:t>$16.8K</a:t>
             </a:r>
             <a:endParaRPr lang="en-US" sz="1300" dirty="0"/>
           </a:p>
@@ -5356,7 +5356,7 @@
         <p:spPr>
           <a:xfrm>
             <a:off x="8220456" y="3247707"/>
-            <a:ext cx="91723" cy="136676"/>
+            <a:ext cx="96551" cy="136676"/>
           </a:xfrm>
           <a:prstGeom prst="rect">
             <a:avLst/>
@@ -5375,8 +5375,8 @@
         </p:nvSpPr>
         <p:spPr>
           <a:xfrm>
-            <a:off x="8970264" y="3191794"/>
-            <a:ext cx="950976" cy="248502"/>
+            <a:off x="9006840" y="3191794"/>
+            <a:ext cx="914400" cy="248502"/>
           </a:xfrm>
           <a:prstGeom prst="rect">
             <a:avLst/>
@@ -5400,7 +5400,7 @@
                 <a:ea typeface="Inter" pitchFamily="34" charset="-122"/>
                 <a:cs typeface="Inter" pitchFamily="34" charset="-120"/>
               </a:rPr>
-              <a:t>$198,802</a:t>
+              <a:t>$199K</a:t>
             </a:r>
             <a:endParaRPr lang="en-US" sz="1300" dirty="0"/>
           </a:p>
@@ -5439,7 +5439,7 @@
                 <a:ea typeface="Inter" pitchFamily="34" charset="-122"/>
                 <a:cs typeface="Inter" pitchFamily="34" charset="-120"/>
               </a:rPr>
-              <a:t>$10,963</a:t>
+              <a:t>$11.0K</a:t>
             </a:r>
             <a:endParaRPr lang="en-US" sz="1300" dirty="0"/>
           </a:p>
@@ -5478,7 +5478,7 @@
                 <a:ea typeface="Inter" pitchFamily="34" charset="-122"/>
                 <a:cs typeface="Inter" pitchFamily="34" charset="-120"/>
               </a:rPr>
-              <a:t>$11,511</a:t>
+              <a:t>$11.5K</a:t>
             </a:r>
             <a:endParaRPr lang="en-US" sz="1300" dirty="0"/>
           </a:p>
@@ -5532,7 +5532,7 @@
         <p:spPr>
           <a:xfrm>
             <a:off x="8220456" y="3496208"/>
-            <a:ext cx="88990" cy="136676"/>
+            <a:ext cx="93673" cy="136676"/>
           </a:xfrm>
           <a:prstGeom prst="rect">
             <a:avLst/>
@@ -5551,8 +5551,8 @@
         </p:nvSpPr>
         <p:spPr>
           <a:xfrm>
-            <a:off x="8970264" y="3440296"/>
-            <a:ext cx="950976" cy="248502"/>
+            <a:off x="9006840" y="3440296"/>
+            <a:ext cx="914400" cy="248502"/>
           </a:xfrm>
           <a:prstGeom prst="rect">
             <a:avLst/>
@@ -5576,7 +5576,7 @@
                 <a:ea typeface="Inter" pitchFamily="34" charset="-122"/>
                 <a:cs typeface="Inter" pitchFamily="34" charset="-120"/>
               </a:rPr>
-              <a:t>$192,877</a:t>
+              <a:t>$193K</a:t>
             </a:r>
             <a:endParaRPr lang="en-US" sz="1300" dirty="0"/>
           </a:p>
@@ -5615,7 +5615,7 @@
                 <a:ea typeface="Inter" pitchFamily="34" charset="-122"/>
                 <a:cs typeface="Inter" pitchFamily="34" charset="-120"/>
               </a:rPr>
-              <a:t>$12,364</a:t>
+              <a:t>$12.4K</a:t>
             </a:r>
             <a:endParaRPr lang="en-US" sz="1300" dirty="0"/>
           </a:p>
@@ -5654,7 +5654,7 @@
                 <a:ea typeface="Inter" pitchFamily="34" charset="-122"/>
                 <a:cs typeface="Inter" pitchFamily="34" charset="-120"/>
               </a:rPr>
-              <a:t>$12,982</a:t>
+              <a:t>$13.0K</a:t>
             </a:r>
             <a:endParaRPr lang="en-US" sz="1300" dirty="0"/>
           </a:p>
@@ -5708,7 +5708,7 @@
         <p:spPr>
           <a:xfrm>
             <a:off x="8220456" y="3744710"/>
-            <a:ext cx="83056" cy="136676"/>
+            <a:ext cx="87427" cy="136676"/>
           </a:xfrm>
           <a:prstGeom prst="rect">
             <a:avLst/>
@@ -5727,8 +5727,8 @@
         </p:nvSpPr>
         <p:spPr>
           <a:xfrm>
-            <a:off x="8970264" y="3688797"/>
-            <a:ext cx="950976" cy="248502"/>
+            <a:off x="9006840" y="3688797"/>
+            <a:ext cx="914400" cy="248502"/>
           </a:xfrm>
           <a:prstGeom prst="rect">
             <a:avLst/>
@@ -5752,7 +5752,7 @@
                 <a:ea typeface="Inter" pitchFamily="34" charset="-122"/>
                 <a:cs typeface="Inter" pitchFamily="34" charset="-120"/>
               </a:rPr>
-              <a:t>$180,016</a:t>
+              <a:t>$180K</a:t>
             </a:r>
             <a:endParaRPr lang="en-US" sz="1300" dirty="0"/>
           </a:p>
@@ -5791,7 +5791,7 @@
                 <a:ea typeface="Inter" pitchFamily="34" charset="-122"/>
                 <a:cs typeface="Inter" pitchFamily="34" charset="-120"/>
               </a:rPr>
-              <a:t>$12,501</a:t>
+              <a:t>$12.5K</a:t>
             </a:r>
             <a:endParaRPr lang="en-US" sz="1300" dirty="0"/>
           </a:p>
@@ -5830,7 +5830,7 @@
                 <a:ea typeface="Inter" pitchFamily="34" charset="-122"/>
                 <a:cs typeface="Inter" pitchFamily="34" charset="-120"/>
               </a:rPr>
-              <a:t>$13,126</a:t>
+              <a:t>$13.1K</a:t>
             </a:r>
             <a:endParaRPr lang="en-US" sz="1300" dirty="0"/>
           </a:p>
@@ -5884,7 +5884,7 @@
         <p:spPr>
           <a:xfrm>
             <a:off x="8220456" y="3993212"/>
-            <a:ext cx="71851" cy="136676"/>
+            <a:ext cx="75632" cy="136676"/>
           </a:xfrm>
           <a:prstGeom prst="rect">
             <a:avLst/>
@@ -5903,8 +5903,8 @@
         </p:nvSpPr>
         <p:spPr>
           <a:xfrm>
-            <a:off x="8970264" y="3937299"/>
-            <a:ext cx="950976" cy="248502"/>
+            <a:off x="9006840" y="3937299"/>
+            <a:ext cx="914400" cy="248502"/>
           </a:xfrm>
           <a:prstGeom prst="rect">
             <a:avLst/>
@@ -5928,7 +5928,7 @@
                 <a:ea typeface="Inter" pitchFamily="34" charset="-122"/>
                 <a:cs typeface="Inter" pitchFamily="34" charset="-120"/>
               </a:rPr>
-              <a:t>$155,730</a:t>
+              <a:t>$156K</a:t>
             </a:r>
             <a:endParaRPr lang="en-US" sz="1300" dirty="0"/>
           </a:p>
@@ -5967,7 +5967,7 @@
                 <a:ea typeface="Inter" pitchFamily="34" charset="-122"/>
                 <a:cs typeface="Inter" pitchFamily="34" charset="-120"/>
               </a:rPr>
-              <a:t>$12,103</a:t>
+              <a:t>$12.1K</a:t>
             </a:r>
             <a:endParaRPr lang="en-US" sz="1300" dirty="0"/>
           </a:p>
@@ -6006,7 +6006,7 @@
                 <a:ea typeface="Inter" pitchFamily="34" charset="-122"/>
                 <a:cs typeface="Inter" pitchFamily="34" charset="-120"/>
               </a:rPr>
-              <a:t>$12,709</a:t>
+              <a:t>$12.7K</a:t>
             </a:r>
             <a:endParaRPr lang="en-US" sz="1300" dirty="0"/>
           </a:p>
@@ -6060,7 +6060,7 @@
         <p:spPr>
           <a:xfrm>
             <a:off x="8220456" y="4241713"/>
-            <a:ext cx="70289" cy="136676"/>
+            <a:ext cx="73988" cy="136676"/>
           </a:xfrm>
           <a:prstGeom prst="rect">
             <a:avLst/>
@@ -6079,8 +6079,8 @@
         </p:nvSpPr>
         <p:spPr>
           <a:xfrm>
-            <a:off x="8970264" y="4185800"/>
-            <a:ext cx="950976" cy="248502"/>
+            <a:off x="9006840" y="4185800"/>
+            <a:ext cx="914400" cy="248502"/>
           </a:xfrm>
           <a:prstGeom prst="rect">
             <a:avLst/>
@@ -6104,7 +6104,7 @@
                 <a:ea typeface="Inter" pitchFamily="34" charset="-122"/>
                 <a:cs typeface="Inter" pitchFamily="34" charset="-120"/>
               </a:rPr>
-              <a:t>$152,344</a:t>
+              <a:t>$152K</a:t>
             </a:r>
             <a:endParaRPr lang="en-US" sz="1300" dirty="0"/>
           </a:p>
@@ -6143,7 +6143,7 @@
                 <a:ea typeface="Inter" pitchFamily="34" charset="-122"/>
                 <a:cs typeface="Inter" pitchFamily="34" charset="-120"/>
               </a:rPr>
-              <a:t>$11,541</a:t>
+              <a:t>$11.5K</a:t>
             </a:r>
             <a:endParaRPr lang="en-US" sz="1300" dirty="0"/>
           </a:p>
@@ -6182,7 +6182,7 @@
                 <a:ea typeface="Inter" pitchFamily="34" charset="-122"/>
                 <a:cs typeface="Inter" pitchFamily="34" charset="-120"/>
               </a:rPr>
-              <a:t>$12,118</a:t>
+              <a:t>$12.1K</a:t>
             </a:r>
             <a:endParaRPr lang="en-US" sz="1300" dirty="0"/>
           </a:p>
@@ -6236,7 +6236,7 @@
         <p:spPr>
           <a:xfrm>
             <a:off x="8220456" y="4490215"/>
-            <a:ext cx="69822" cy="136676"/>
+            <a:ext cx="73497" cy="136676"/>
           </a:xfrm>
           <a:prstGeom prst="rect">
             <a:avLst/>
@@ -6255,8 +6255,8 @@
         </p:nvSpPr>
         <p:spPr>
           <a:xfrm>
-            <a:off x="8970264" y="4434302"/>
-            <a:ext cx="950976" cy="248502"/>
+            <a:off x="9006840" y="4434302"/>
+            <a:ext cx="914400" cy="248502"/>
           </a:xfrm>
           <a:prstGeom prst="rect">
             <a:avLst/>
@@ -6280,7 +6280,7 @@
                 <a:ea typeface="Inter" pitchFamily="34" charset="-122"/>
                 <a:cs typeface="Inter" pitchFamily="34" charset="-120"/>
               </a:rPr>
-              <a:t>$151,334</a:t>
+              <a:t>$151K</a:t>
             </a:r>
             <a:endParaRPr lang="en-US" sz="1300" dirty="0"/>
           </a:p>
@@ -6319,7 +6319,7 @@
                 <a:ea typeface="Inter" pitchFamily="34" charset="-122"/>
                 <a:cs typeface="Inter" pitchFamily="34" charset="-120"/>
               </a:rPr>
-              <a:t>$9,498</a:t>
+              <a:t>$9.5K</a:t>
             </a:r>
             <a:endParaRPr lang="en-US" sz="1300" dirty="0"/>
           </a:p>
@@ -6358,7 +6358,7 @@
                 <a:ea typeface="Inter" pitchFamily="34" charset="-122"/>
                 <a:cs typeface="Inter" pitchFamily="34" charset="-120"/>
               </a:rPr>
-              <a:t>$9,973</a:t>
+              <a:t>$10.0K</a:t>
             </a:r>
             <a:endParaRPr lang="en-US" sz="1300" dirty="0"/>
           </a:p>
@@ -6412,7 +6412,7 @@
         <p:spPr>
           <a:xfrm>
             <a:off x="8220456" y="4738717"/>
-            <a:ext cx="67909" cy="136676"/>
+            <a:ext cx="71484" cy="136676"/>
           </a:xfrm>
           <a:prstGeom prst="rect">
             <a:avLst/>
@@ -6431,8 +6431,8 @@
         </p:nvSpPr>
         <p:spPr>
           <a:xfrm>
-            <a:off x="8970264" y="4682804"/>
-            <a:ext cx="950976" cy="248502"/>
+            <a:off x="9006840" y="4682804"/>
+            <a:ext cx="914400" cy="248502"/>
           </a:xfrm>
           <a:prstGeom prst="rect">
             <a:avLst/>
@@ -6456,7 +6456,7 @@
                 <a:ea typeface="Inter" pitchFamily="34" charset="-122"/>
                 <a:cs typeface="Inter" pitchFamily="34" charset="-120"/>
               </a:rPr>
-              <a:t>$147,187</a:t>
+              <a:t>$147K</a:t>
             </a:r>
             <a:endParaRPr lang="en-US" sz="1300" dirty="0"/>
           </a:p>
@@ -6495,7 +6495,7 @@
                 <a:ea typeface="Inter" pitchFamily="34" charset="-122"/>
                 <a:cs typeface="Inter" pitchFamily="34" charset="-120"/>
               </a:rPr>
-              <a:t>$15,226</a:t>
+              <a:t>$15.2K</a:t>
             </a:r>
             <a:endParaRPr lang="en-US" sz="1300" dirty="0"/>
           </a:p>
@@ -6534,7 +6534,7 @@
                 <a:ea typeface="Inter" pitchFamily="34" charset="-122"/>
                 <a:cs typeface="Inter" pitchFamily="34" charset="-120"/>
               </a:rPr>
-              <a:t>$15,988</a:t>
+              <a:t>$16.0K</a:t>
             </a:r>
             <a:endParaRPr lang="en-US" sz="1300" dirty="0"/>
           </a:p>
@@ -6588,7 +6588,7 @@
         <p:spPr>
           <a:xfrm>
             <a:off x="8220456" y="4987218"/>
-            <a:ext cx="48967" cy="136676"/>
+            <a:ext cx="51544" cy="136676"/>
           </a:xfrm>
           <a:prstGeom prst="rect">
             <a:avLst/>
@@ -6607,8 +6607,8 @@
         </p:nvSpPr>
         <p:spPr>
           <a:xfrm>
-            <a:off x="8970264" y="4931305"/>
-            <a:ext cx="950976" cy="248502"/>
+            <a:off x="9006840" y="4931305"/>
+            <a:ext cx="914400" cy="248502"/>
           </a:xfrm>
           <a:prstGeom prst="rect">
             <a:avLst/>
@@ -6632,7 +6632,7 @@
                 <a:ea typeface="Inter" pitchFamily="34" charset="-122"/>
                 <a:cs typeface="Inter" pitchFamily="34" charset="-120"/>
               </a:rPr>
-              <a:t>$106,131</a:t>
+              <a:t>$106K</a:t>
             </a:r>
             <a:endParaRPr lang="en-US" sz="1300" dirty="0"/>
           </a:p>
@@ -6671,7 +6671,7 @@
                 <a:ea typeface="Inter" pitchFamily="34" charset="-122"/>
                 <a:cs typeface="Inter" pitchFamily="34" charset="-120"/>
               </a:rPr>
-              <a:t>$9,149</a:t>
+              <a:t>$9.1K</a:t>
             </a:r>
             <a:endParaRPr lang="en-US" sz="1300" dirty="0"/>
           </a:p>
@@ -6710,7 +6710,7 @@
                 <a:ea typeface="Inter" pitchFamily="34" charset="-122"/>
                 <a:cs typeface="Inter" pitchFamily="34" charset="-120"/>
               </a:rPr>
-              <a:t>$9,607</a:t>
+              <a:t>$9.6K</a:t>
             </a:r>
             <a:endParaRPr lang="en-US" sz="1300" dirty="0"/>
           </a:p>
@@ -6764,7 +6764,7 @@
         <p:spPr>
           <a:xfrm>
             <a:off x="8220456" y="5235720"/>
-            <a:ext cx="47223" cy="136676"/>
+            <a:ext cx="49708" cy="136676"/>
           </a:xfrm>
           <a:prstGeom prst="rect">
             <a:avLst/>
@@ -6783,8 +6783,8 @@
         </p:nvSpPr>
         <p:spPr>
           <a:xfrm>
-            <a:off x="8970264" y="5179807"/>
-            <a:ext cx="950976" cy="248502"/>
+            <a:off x="9006840" y="5179807"/>
+            <a:ext cx="914400" cy="248502"/>
           </a:xfrm>
           <a:prstGeom prst="rect">
             <a:avLst/>
@@ -6808,7 +6808,7 @@
                 <a:ea typeface="Inter" pitchFamily="34" charset="-122"/>
                 <a:cs typeface="Inter" pitchFamily="34" charset="-120"/>
               </a:rPr>
-              <a:t>$102,351</a:t>
+              <a:t>$102K</a:t>
             </a:r>
             <a:endParaRPr lang="en-US" sz="1300" dirty="0"/>
           </a:p>
@@ -6847,7 +6847,7 @@
                 <a:ea typeface="Inter" pitchFamily="34" charset="-122"/>
                 <a:cs typeface="Inter" pitchFamily="34" charset="-120"/>
               </a:rPr>
-              <a:t>$11,631</a:t>
+              <a:t>$11.6K</a:t>
             </a:r>
             <a:endParaRPr lang="en-US" sz="1300" dirty="0"/>
           </a:p>
@@ -6886,7 +6886,7 @@
                 <a:ea typeface="Inter" pitchFamily="34" charset="-122"/>
                 <a:cs typeface="Inter" pitchFamily="34" charset="-120"/>
               </a:rPr>
-              <a:t>$12,212</a:t>
+              <a:t>$12.2K</a:t>
             </a:r>
             <a:endParaRPr lang="en-US" sz="1300" dirty="0"/>
           </a:p>
@@ -6940,7 +6940,7 @@
         <p:spPr>
           <a:xfrm>
             <a:off x="8220456" y="5484222"/>
-            <a:ext cx="29775" cy="136676"/>
+            <a:ext cx="31342" cy="136676"/>
           </a:xfrm>
           <a:prstGeom prst="rect">
             <a:avLst/>
@@ -6959,8 +6959,8 @@
         </p:nvSpPr>
         <p:spPr>
           <a:xfrm>
-            <a:off x="8970264" y="5428309"/>
-            <a:ext cx="950976" cy="248502"/>
+            <a:off x="9006840" y="5428309"/>
+            <a:ext cx="914400" cy="248502"/>
           </a:xfrm>
           <a:prstGeom prst="rect">
             <a:avLst/>
@@ -6984,7 +6984,7 @@
                 <a:ea typeface="Inter" pitchFamily="34" charset="-122"/>
                 <a:cs typeface="Inter" pitchFamily="34" charset="-120"/>
               </a:rPr>
-              <a:t>$64,535</a:t>
+              <a:t>$65K</a:t>
             </a:r>
             <a:endParaRPr lang="en-US" sz="1300" dirty="0"/>
           </a:p>
@@ -7023,7 +7023,7 @@
                 <a:ea typeface="Inter" pitchFamily="34" charset="-122"/>
                 <a:cs typeface="Inter" pitchFamily="34" charset="-120"/>
               </a:rPr>
-              <a:t>$9,878</a:t>
+              <a:t>$9.9K</a:t>
             </a:r>
             <a:endParaRPr lang="en-US" sz="1300" dirty="0"/>
           </a:p>
@@ -7062,7 +7062,7 @@
                 <a:ea typeface="Inter" pitchFamily="34" charset="-122"/>
                 <a:cs typeface="Inter" pitchFamily="34" charset="-120"/>
               </a:rPr>
-              <a:t>$10,372</a:t>
+              <a:t>$10.4K</a:t>
             </a:r>
             <a:endParaRPr lang="en-US" sz="1300" dirty="0"/>
           </a:p>

</xml_diff>